<commit_message>
feat: add frontend layout, navigation, and core analysis pages
</commit_message>
<xml_diff>
--- a/Packet_Analysis_Presentation_Clean.pptx
+++ b/Packet_Analysis_Presentation_Clean.pptx
@@ -5,16 +5,16 @@
     <p:sldMasterId id="2147483648" r:id="rId1"/>
   </p:sldMasterIdLst>
   <p:sldIdLst>
-    <p:sldId id="256" r:id="rId7"/>
-    <p:sldId id="257" r:id="rId8"/>
-    <p:sldId id="258" r:id="rId9"/>
-    <p:sldId id="259" r:id="rId10"/>
-    <p:sldId id="260" r:id="rId11"/>
-    <p:sldId id="261" r:id="rId12"/>
-    <p:sldId id="262" r:id="rId13"/>
-    <p:sldId id="263" r:id="rId14"/>
+    <p:sldId id="256" r:id="rId2"/>
+    <p:sldId id="257" r:id="rId3"/>
+    <p:sldId id="258" r:id="rId4"/>
+    <p:sldId id="259" r:id="rId5"/>
+    <p:sldId id="260" r:id="rId6"/>
+    <p:sldId id="261" r:id="rId7"/>
+    <p:sldId id="262" r:id="rId8"/>
+    <p:sldId id="263" r:id="rId9"/>
   </p:sldIdLst>
-  <p:sldSz cx="12191695" cy="6858000" type="screen4x3"/>
+  <p:sldSz cx="12192000" cy="6858000"/>
   <p:notesSz cx="6858000" cy="9144000"/>
   <p:defaultTextStyle>
     <a:defPPr>
@@ -111,6 +111,22 @@
       </a:defRPr>
     </a:lvl9pPr>
   </p:defaultTextStyle>
+  <p:extLst>
+    <p:ext uri="{EFAFB233-063F-42B5-8137-9DF3F51BA10A}">
+      <p15:sldGuideLst xmlns:p15="http://schemas.microsoft.com/office/powerpoint/2012/main">
+        <p15:guide id="1" orient="horz" pos="2160">
+          <p15:clr>
+            <a:srgbClr val="A4A3A4"/>
+          </p15:clr>
+        </p15:guide>
+        <p15:guide id="2" pos="2880">
+          <p15:clr>
+            <a:srgbClr val="A4A3A4"/>
+          </p15:clr>
+        </p15:guide>
+      </p15:sldGuideLst>
+    </p:ext>
+  </p:extLst>
 </p:presentation>
 </file>
 
@@ -152,10 +168,9 @@
           <a:lstStyle/>
           <a:p>
             <a:r>
-              <a:rPr lang="en-US" smtClean="0"/>
+              <a:rPr lang="en-US"/>
               <a:t>Click to edit Master title style</a:t>
             </a:r>
-            <a:endParaRPr lang="en-US"/>
           </a:p>
         </p:txBody>
       </p:sp>
@@ -271,10 +286,9 @@
           </a:lstStyle>
           <a:p>
             <a:r>
-              <a:rPr lang="en-US" smtClean="0"/>
+              <a:rPr lang="en-US"/>
               <a:t>Click to edit Master subtitle style</a:t>
             </a:r>
-            <a:endParaRPr lang="en-US"/>
           </a:p>
         </p:txBody>
       </p:sp>
@@ -295,7 +309,7 @@
           <a:p>
             <a:fld id="{5BCAD085-E8A6-8845-BD4E-CB4CCA059FC4}" type="datetimeFigureOut">
               <a:rPr lang="en-US" smtClean="0"/>
-              <a:t>1/27/13</a:t>
+              <a:t>10/8/2026</a:t>
             </a:fld>
             <a:endParaRPr lang="en-US"/>
           </a:p>
@@ -389,10 +403,9 @@
           <a:lstStyle/>
           <a:p>
             <a:r>
-              <a:rPr lang="en-US" smtClean="0"/>
+              <a:rPr lang="en-US"/>
               <a:t>Click to edit Master title style</a:t>
             </a:r>
-            <a:endParaRPr lang="en-US"/>
           </a:p>
         </p:txBody>
       </p:sp>
@@ -413,38 +426,37 @@
           <a:p>
             <a:pPr lvl="0"/>
             <a:r>
-              <a:rPr lang="en-US" smtClean="0"/>
+              <a:rPr lang="en-US"/>
               <a:t>Click to edit Master text styles</a:t>
             </a:r>
           </a:p>
           <a:p>
             <a:pPr lvl="1"/>
             <a:r>
-              <a:rPr lang="en-US" smtClean="0"/>
+              <a:rPr lang="en-US"/>
               <a:t>Second level</a:t>
             </a:r>
           </a:p>
           <a:p>
             <a:pPr lvl="2"/>
             <a:r>
-              <a:rPr lang="en-US" smtClean="0"/>
+              <a:rPr lang="en-US"/>
               <a:t>Third level</a:t>
             </a:r>
           </a:p>
           <a:p>
             <a:pPr lvl="3"/>
             <a:r>
-              <a:rPr lang="en-US" smtClean="0"/>
+              <a:rPr lang="en-US"/>
               <a:t>Fourth level</a:t>
             </a:r>
           </a:p>
           <a:p>
             <a:pPr lvl="4"/>
             <a:r>
-              <a:rPr lang="en-US" smtClean="0"/>
+              <a:rPr lang="en-US"/>
               <a:t>Fifth level</a:t>
             </a:r>
-            <a:endParaRPr lang="en-US"/>
           </a:p>
         </p:txBody>
       </p:sp>
@@ -465,7 +477,7 @@
           <a:p>
             <a:fld id="{5BCAD085-E8A6-8845-BD4E-CB4CCA059FC4}" type="datetimeFigureOut">
               <a:rPr lang="en-US" smtClean="0"/>
-              <a:t>1/27/13</a:t>
+              <a:t>10/8/2026</a:t>
             </a:fld>
             <a:endParaRPr lang="en-US"/>
           </a:p>
@@ -564,10 +576,9 @@
           <a:lstStyle/>
           <a:p>
             <a:r>
-              <a:rPr lang="en-US" smtClean="0"/>
+              <a:rPr lang="en-US"/>
               <a:t>Click to edit Master title style</a:t>
             </a:r>
-            <a:endParaRPr lang="en-US"/>
           </a:p>
         </p:txBody>
       </p:sp>
@@ -593,38 +604,37 @@
           <a:p>
             <a:pPr lvl="0"/>
             <a:r>
-              <a:rPr lang="en-US" smtClean="0"/>
+              <a:rPr lang="en-US"/>
               <a:t>Click to edit Master text styles</a:t>
             </a:r>
           </a:p>
           <a:p>
             <a:pPr lvl="1"/>
             <a:r>
-              <a:rPr lang="en-US" smtClean="0"/>
+              <a:rPr lang="en-US"/>
               <a:t>Second level</a:t>
             </a:r>
           </a:p>
           <a:p>
             <a:pPr lvl="2"/>
             <a:r>
-              <a:rPr lang="en-US" smtClean="0"/>
+              <a:rPr lang="en-US"/>
               <a:t>Third level</a:t>
             </a:r>
           </a:p>
           <a:p>
             <a:pPr lvl="3"/>
             <a:r>
-              <a:rPr lang="en-US" smtClean="0"/>
+              <a:rPr lang="en-US"/>
               <a:t>Fourth level</a:t>
             </a:r>
           </a:p>
           <a:p>
             <a:pPr lvl="4"/>
             <a:r>
-              <a:rPr lang="en-US" smtClean="0"/>
+              <a:rPr lang="en-US"/>
               <a:t>Fifth level</a:t>
             </a:r>
-            <a:endParaRPr lang="en-US"/>
           </a:p>
         </p:txBody>
       </p:sp>
@@ -645,7 +655,7 @@
           <a:p>
             <a:fld id="{5BCAD085-E8A6-8845-BD4E-CB4CCA059FC4}" type="datetimeFigureOut">
               <a:rPr lang="en-US" smtClean="0"/>
-              <a:t>1/27/13</a:t>
+              <a:t>10/8/2026</a:t>
             </a:fld>
             <a:endParaRPr lang="en-US"/>
           </a:p>
@@ -739,10 +749,9 @@
           <a:lstStyle/>
           <a:p>
             <a:r>
-              <a:rPr lang="en-US" smtClean="0"/>
+              <a:rPr lang="en-US"/>
               <a:t>Click to edit Master title style</a:t>
             </a:r>
-            <a:endParaRPr lang="en-US"/>
           </a:p>
         </p:txBody>
       </p:sp>
@@ -763,38 +772,37 @@
           <a:p>
             <a:pPr lvl="0"/>
             <a:r>
-              <a:rPr lang="en-US" smtClean="0"/>
+              <a:rPr lang="en-US"/>
               <a:t>Click to edit Master text styles</a:t>
             </a:r>
           </a:p>
           <a:p>
             <a:pPr lvl="1"/>
             <a:r>
-              <a:rPr lang="en-US" smtClean="0"/>
+              <a:rPr lang="en-US"/>
               <a:t>Second level</a:t>
             </a:r>
           </a:p>
           <a:p>
             <a:pPr lvl="2"/>
             <a:r>
-              <a:rPr lang="en-US" smtClean="0"/>
+              <a:rPr lang="en-US"/>
               <a:t>Third level</a:t>
             </a:r>
           </a:p>
           <a:p>
             <a:pPr lvl="3"/>
             <a:r>
-              <a:rPr lang="en-US" smtClean="0"/>
+              <a:rPr lang="en-US"/>
               <a:t>Fourth level</a:t>
             </a:r>
           </a:p>
           <a:p>
             <a:pPr lvl="4"/>
             <a:r>
-              <a:rPr lang="en-US" smtClean="0"/>
+              <a:rPr lang="en-US"/>
               <a:t>Fifth level</a:t>
             </a:r>
-            <a:endParaRPr lang="en-US"/>
           </a:p>
         </p:txBody>
       </p:sp>
@@ -815,7 +823,7 @@
           <a:p>
             <a:fld id="{5BCAD085-E8A6-8845-BD4E-CB4CCA059FC4}" type="datetimeFigureOut">
               <a:rPr lang="en-US" smtClean="0"/>
-              <a:t>1/27/13</a:t>
+              <a:t>10/8/2026</a:t>
             </a:fld>
             <a:endParaRPr lang="en-US"/>
           </a:p>
@@ -918,10 +926,9 @@
           </a:lstStyle>
           <a:p>
             <a:r>
-              <a:rPr lang="en-US" smtClean="0"/>
+              <a:rPr lang="en-US"/>
               <a:t>Click to edit Master title style</a:t>
             </a:r>
-            <a:endParaRPr lang="en-US"/>
           </a:p>
         </p:txBody>
       </p:sp>
@@ -1038,7 +1045,7 @@
           <a:p>
             <a:pPr lvl="0"/>
             <a:r>
-              <a:rPr lang="en-US" smtClean="0"/>
+              <a:rPr lang="en-US"/>
               <a:t>Click to edit Master text styles</a:t>
             </a:r>
           </a:p>
@@ -1061,7 +1068,7 @@
           <a:p>
             <a:fld id="{5BCAD085-E8A6-8845-BD4E-CB4CCA059FC4}" type="datetimeFigureOut">
               <a:rPr lang="en-US" smtClean="0"/>
-              <a:t>1/27/13</a:t>
+              <a:t>10/8/2026</a:t>
             </a:fld>
             <a:endParaRPr lang="en-US"/>
           </a:p>
@@ -1155,10 +1162,9 @@
           <a:lstStyle/>
           <a:p>
             <a:r>
-              <a:rPr lang="en-US" smtClean="0"/>
+              <a:rPr lang="en-US"/>
               <a:t>Click to edit Master title style</a:t>
             </a:r>
-            <a:endParaRPr lang="en-US"/>
           </a:p>
         </p:txBody>
       </p:sp>
@@ -1212,38 +1218,37 @@
           <a:p>
             <a:pPr lvl="0"/>
             <a:r>
-              <a:rPr lang="en-US" smtClean="0"/>
+              <a:rPr lang="en-US"/>
               <a:t>Click to edit Master text styles</a:t>
             </a:r>
           </a:p>
           <a:p>
             <a:pPr lvl="1"/>
             <a:r>
-              <a:rPr lang="en-US" smtClean="0"/>
+              <a:rPr lang="en-US"/>
               <a:t>Second level</a:t>
             </a:r>
           </a:p>
           <a:p>
             <a:pPr lvl="2"/>
             <a:r>
-              <a:rPr lang="en-US" smtClean="0"/>
+              <a:rPr lang="en-US"/>
               <a:t>Third level</a:t>
             </a:r>
           </a:p>
           <a:p>
             <a:pPr lvl="3"/>
             <a:r>
-              <a:rPr lang="en-US" smtClean="0"/>
+              <a:rPr lang="en-US"/>
               <a:t>Fourth level</a:t>
             </a:r>
           </a:p>
           <a:p>
             <a:pPr lvl="4"/>
             <a:r>
-              <a:rPr lang="en-US" smtClean="0"/>
+              <a:rPr lang="en-US"/>
               <a:t>Fifth level</a:t>
             </a:r>
-            <a:endParaRPr lang="en-US"/>
           </a:p>
         </p:txBody>
       </p:sp>
@@ -1297,38 +1302,37 @@
           <a:p>
             <a:pPr lvl="0"/>
             <a:r>
-              <a:rPr lang="en-US" smtClean="0"/>
+              <a:rPr lang="en-US"/>
               <a:t>Click to edit Master text styles</a:t>
             </a:r>
           </a:p>
           <a:p>
             <a:pPr lvl="1"/>
             <a:r>
-              <a:rPr lang="en-US" smtClean="0"/>
+              <a:rPr lang="en-US"/>
               <a:t>Second level</a:t>
             </a:r>
           </a:p>
           <a:p>
             <a:pPr lvl="2"/>
             <a:r>
-              <a:rPr lang="en-US" smtClean="0"/>
+              <a:rPr lang="en-US"/>
               <a:t>Third level</a:t>
             </a:r>
           </a:p>
           <a:p>
             <a:pPr lvl="3"/>
             <a:r>
-              <a:rPr lang="en-US" smtClean="0"/>
+              <a:rPr lang="en-US"/>
               <a:t>Fourth level</a:t>
             </a:r>
           </a:p>
           <a:p>
             <a:pPr lvl="4"/>
             <a:r>
-              <a:rPr lang="en-US" smtClean="0"/>
+              <a:rPr lang="en-US"/>
               <a:t>Fifth level</a:t>
             </a:r>
-            <a:endParaRPr lang="en-US"/>
           </a:p>
         </p:txBody>
       </p:sp>
@@ -1349,7 +1353,7 @@
           <a:p>
             <a:fld id="{5BCAD085-E8A6-8845-BD4E-CB4CCA059FC4}" type="datetimeFigureOut">
               <a:rPr lang="en-US" smtClean="0"/>
-              <a:t>1/27/13</a:t>
+              <a:t>10/8/2026</a:t>
             </a:fld>
             <a:endParaRPr lang="en-US"/>
           </a:p>
@@ -1447,10 +1451,9 @@
           </a:lstStyle>
           <a:p>
             <a:r>
-              <a:rPr lang="en-US" smtClean="0"/>
+              <a:rPr lang="en-US"/>
               <a:t>Click to edit Master title style</a:t>
             </a:r>
-            <a:endParaRPr lang="en-US"/>
           </a:p>
         </p:txBody>
       </p:sp>
@@ -1513,7 +1516,7 @@
           <a:p>
             <a:pPr lvl="0"/>
             <a:r>
-              <a:rPr lang="en-US" smtClean="0"/>
+              <a:rPr lang="en-US"/>
               <a:t>Click to edit Master text styles</a:t>
             </a:r>
           </a:p>
@@ -1569,38 +1572,37 @@
           <a:p>
             <a:pPr lvl="0"/>
             <a:r>
-              <a:rPr lang="en-US" smtClean="0"/>
+              <a:rPr lang="en-US"/>
               <a:t>Click to edit Master text styles</a:t>
             </a:r>
           </a:p>
           <a:p>
             <a:pPr lvl="1"/>
             <a:r>
-              <a:rPr lang="en-US" smtClean="0"/>
+              <a:rPr lang="en-US"/>
               <a:t>Second level</a:t>
             </a:r>
           </a:p>
           <a:p>
             <a:pPr lvl="2"/>
             <a:r>
-              <a:rPr lang="en-US" smtClean="0"/>
+              <a:rPr lang="en-US"/>
               <a:t>Third level</a:t>
             </a:r>
           </a:p>
           <a:p>
             <a:pPr lvl="3"/>
             <a:r>
-              <a:rPr lang="en-US" smtClean="0"/>
+              <a:rPr lang="en-US"/>
               <a:t>Fourth level</a:t>
             </a:r>
           </a:p>
           <a:p>
             <a:pPr lvl="4"/>
             <a:r>
-              <a:rPr lang="en-US" smtClean="0"/>
+              <a:rPr lang="en-US"/>
               <a:t>Fifth level</a:t>
             </a:r>
-            <a:endParaRPr lang="en-US"/>
           </a:p>
         </p:txBody>
       </p:sp>
@@ -1663,7 +1665,7 @@
           <a:p>
             <a:pPr lvl="0"/>
             <a:r>
-              <a:rPr lang="en-US" smtClean="0"/>
+              <a:rPr lang="en-US"/>
               <a:t>Click to edit Master text styles</a:t>
             </a:r>
           </a:p>
@@ -1719,38 +1721,37 @@
           <a:p>
             <a:pPr lvl="0"/>
             <a:r>
-              <a:rPr lang="en-US" smtClean="0"/>
+              <a:rPr lang="en-US"/>
               <a:t>Click to edit Master text styles</a:t>
             </a:r>
           </a:p>
           <a:p>
             <a:pPr lvl="1"/>
             <a:r>
-              <a:rPr lang="en-US" smtClean="0"/>
+              <a:rPr lang="en-US"/>
               <a:t>Second level</a:t>
             </a:r>
           </a:p>
           <a:p>
             <a:pPr lvl="2"/>
             <a:r>
-              <a:rPr lang="en-US" smtClean="0"/>
+              <a:rPr lang="en-US"/>
               <a:t>Third level</a:t>
             </a:r>
           </a:p>
           <a:p>
             <a:pPr lvl="3"/>
             <a:r>
-              <a:rPr lang="en-US" smtClean="0"/>
+              <a:rPr lang="en-US"/>
               <a:t>Fourth level</a:t>
             </a:r>
           </a:p>
           <a:p>
             <a:pPr lvl="4"/>
             <a:r>
-              <a:rPr lang="en-US" smtClean="0"/>
+              <a:rPr lang="en-US"/>
               <a:t>Fifth level</a:t>
             </a:r>
-            <a:endParaRPr lang="en-US"/>
           </a:p>
         </p:txBody>
       </p:sp>
@@ -1771,7 +1772,7 @@
           <a:p>
             <a:fld id="{5BCAD085-E8A6-8845-BD4E-CB4CCA059FC4}" type="datetimeFigureOut">
               <a:rPr lang="en-US" smtClean="0"/>
-              <a:t>1/27/13</a:t>
+              <a:t>10/8/2026</a:t>
             </a:fld>
             <a:endParaRPr lang="en-US"/>
           </a:p>
@@ -1865,10 +1866,9 @@
           <a:lstStyle/>
           <a:p>
             <a:r>
-              <a:rPr lang="en-US" smtClean="0"/>
+              <a:rPr lang="en-US"/>
               <a:t>Click to edit Master title style</a:t>
             </a:r>
-            <a:endParaRPr lang="en-US"/>
           </a:p>
         </p:txBody>
       </p:sp>
@@ -1889,7 +1889,7 @@
           <a:p>
             <a:fld id="{5BCAD085-E8A6-8845-BD4E-CB4CCA059FC4}" type="datetimeFigureOut">
               <a:rPr lang="en-US" smtClean="0"/>
-              <a:t>1/27/13</a:t>
+              <a:t>10/8/2026</a:t>
             </a:fld>
             <a:endParaRPr lang="en-US"/>
           </a:p>
@@ -1984,7 +1984,7 @@
           <a:p>
             <a:fld id="{5BCAD085-E8A6-8845-BD4E-CB4CCA059FC4}" type="datetimeFigureOut">
               <a:rPr lang="en-US" smtClean="0"/>
-              <a:t>1/27/13</a:t>
+              <a:t>10/8/2026</a:t>
             </a:fld>
             <a:endParaRPr lang="en-US"/>
           </a:p>
@@ -2087,10 +2087,9 @@
           </a:lstStyle>
           <a:p>
             <a:r>
-              <a:rPr lang="en-US" smtClean="0"/>
+              <a:rPr lang="en-US"/>
               <a:t>Click to edit Master title style</a:t>
             </a:r>
-            <a:endParaRPr lang="en-US"/>
           </a:p>
         </p:txBody>
       </p:sp>
@@ -2144,38 +2143,37 @@
           <a:p>
             <a:pPr lvl="0"/>
             <a:r>
-              <a:rPr lang="en-US" smtClean="0"/>
+              <a:rPr lang="en-US"/>
               <a:t>Click to edit Master text styles</a:t>
             </a:r>
           </a:p>
           <a:p>
             <a:pPr lvl="1"/>
             <a:r>
-              <a:rPr lang="en-US" smtClean="0"/>
+              <a:rPr lang="en-US"/>
               <a:t>Second level</a:t>
             </a:r>
           </a:p>
           <a:p>
             <a:pPr lvl="2"/>
             <a:r>
-              <a:rPr lang="en-US" smtClean="0"/>
+              <a:rPr lang="en-US"/>
               <a:t>Third level</a:t>
             </a:r>
           </a:p>
           <a:p>
             <a:pPr lvl="3"/>
             <a:r>
-              <a:rPr lang="en-US" smtClean="0"/>
+              <a:rPr lang="en-US"/>
               <a:t>Fourth level</a:t>
             </a:r>
           </a:p>
           <a:p>
             <a:pPr lvl="4"/>
             <a:r>
-              <a:rPr lang="en-US" smtClean="0"/>
+              <a:rPr lang="en-US"/>
               <a:t>Fifth level</a:t>
             </a:r>
-            <a:endParaRPr lang="en-US"/>
           </a:p>
         </p:txBody>
       </p:sp>
@@ -2238,7 +2236,7 @@
           <a:p>
             <a:pPr lvl="0"/>
             <a:r>
-              <a:rPr lang="en-US" smtClean="0"/>
+              <a:rPr lang="en-US"/>
               <a:t>Click to edit Master text styles</a:t>
             </a:r>
           </a:p>
@@ -2261,7 +2259,7 @@
           <a:p>
             <a:fld id="{5BCAD085-E8A6-8845-BD4E-CB4CCA059FC4}" type="datetimeFigureOut">
               <a:rPr lang="en-US" smtClean="0"/>
-              <a:t>1/27/13</a:t>
+              <a:t>10/8/2026</a:t>
             </a:fld>
             <a:endParaRPr lang="en-US"/>
           </a:p>
@@ -2364,10 +2362,9 @@
           </a:lstStyle>
           <a:p>
             <a:r>
-              <a:rPr lang="en-US" smtClean="0"/>
+              <a:rPr lang="en-US"/>
               <a:t>Click to edit Master title style</a:t>
             </a:r>
-            <a:endParaRPr lang="en-US"/>
           </a:p>
         </p:txBody>
       </p:sp>
@@ -2491,7 +2488,7 @@
           <a:p>
             <a:pPr lvl="0"/>
             <a:r>
-              <a:rPr lang="en-US" smtClean="0"/>
+              <a:rPr lang="en-US"/>
               <a:t>Click to edit Master text styles</a:t>
             </a:r>
           </a:p>
@@ -2514,7 +2511,7 @@
           <a:p>
             <a:fld id="{5BCAD085-E8A6-8845-BD4E-CB4CCA059FC4}" type="datetimeFigureOut">
               <a:rPr lang="en-US" smtClean="0"/>
-              <a:t>1/27/13</a:t>
+              <a:t>10/8/2026</a:t>
             </a:fld>
             <a:endParaRPr lang="en-US"/>
           </a:p>
@@ -2623,10 +2620,9 @@
           <a:lstStyle/>
           <a:p>
             <a:r>
-              <a:rPr lang="en-US" smtClean="0"/>
+              <a:rPr lang="en-US"/>
               <a:t>Click to edit Master title style</a:t>
             </a:r>
-            <a:endParaRPr lang="en-US"/>
           </a:p>
         </p:txBody>
       </p:sp>
@@ -2657,38 +2653,37 @@
           <a:p>
             <a:pPr lvl="0"/>
             <a:r>
-              <a:rPr lang="en-US" smtClean="0"/>
+              <a:rPr lang="en-US"/>
               <a:t>Click to edit Master text styles</a:t>
             </a:r>
           </a:p>
           <a:p>
             <a:pPr lvl="1"/>
             <a:r>
-              <a:rPr lang="en-US" smtClean="0"/>
+              <a:rPr lang="en-US"/>
               <a:t>Second level</a:t>
             </a:r>
           </a:p>
           <a:p>
             <a:pPr lvl="2"/>
             <a:r>
-              <a:rPr lang="en-US" smtClean="0"/>
+              <a:rPr lang="en-US"/>
               <a:t>Third level</a:t>
             </a:r>
           </a:p>
           <a:p>
             <a:pPr lvl="3"/>
             <a:r>
-              <a:rPr lang="en-US" smtClean="0"/>
+              <a:rPr lang="en-US"/>
               <a:t>Fourth level</a:t>
             </a:r>
           </a:p>
           <a:p>
             <a:pPr lvl="4"/>
             <a:r>
-              <a:rPr lang="en-US" smtClean="0"/>
+              <a:rPr lang="en-US"/>
               <a:t>Fifth level</a:t>
             </a:r>
-            <a:endParaRPr lang="en-US"/>
           </a:p>
         </p:txBody>
       </p:sp>
@@ -2727,7 +2722,7 @@
           <a:p>
             <a:fld id="{5BCAD085-E8A6-8845-BD4E-CB4CCA059FC4}" type="datetimeFigureOut">
               <a:rPr lang="en-US" smtClean="0"/>
-              <a:t>1/27/13</a:t>
+              <a:t>10/8/2026</a:t>
             </a:fld>
             <a:endParaRPr lang="en-US"/>
           </a:p>
@@ -3086,7 +3081,7 @@
 </file>
 
 <file path=ppt/slides/slide1.xml><?xml version="1.0" encoding="utf-8"?>
-<p:sld xmlns:a="http://schemas.openxmlformats.org/drawingml/2006/main" xmlns:p="http://schemas.openxmlformats.org/presentationml/2006/main" xmlns:r="http://schemas.openxmlformats.org/officeDocument/2006/relationships">
+<p:sld xmlns:a="http://schemas.openxmlformats.org/drawingml/2006/main" xmlns:r="http://schemas.openxmlformats.org/officeDocument/2006/relationships" xmlns:p="http://schemas.openxmlformats.org/presentationml/2006/main">
   <p:cSld>
     <p:spTree>
       <p:nvGrpSpPr>
@@ -3094,7 +3089,14 @@
         <p:cNvGrpSpPr/>
         <p:nvPr/>
       </p:nvGrpSpPr>
-      <p:grpSpPr/>
+      <p:grpSpPr>
+        <a:xfrm>
+          <a:off x="0" y="0"/>
+          <a:ext cx="0" cy="0"/>
+          <a:chOff x="0" y="0"/>
+          <a:chExt cx="0" cy="0"/>
+        </a:xfrm>
+      </p:grpSpPr>
       <p:sp>
         <p:nvSpPr>
           <p:cNvPr id="2" name="Rectangle 1"/>
@@ -3135,49 +3137,7 @@
           <a:lstStyle/>
           <a:p>
             <a:pPr algn="ctr"/>
-          </a:p>
-        </p:txBody>
-      </p:sp>
-      <p:sp>
-        <p:nvSpPr>
-          <p:cNvPr id="3" name="Rounded Rectangle 2"/>
-          <p:cNvSpPr/>
-          <p:nvPr/>
-        </p:nvSpPr>
-        <p:spPr>
-          <a:xfrm>
-            <a:off x="822960" y="1097280"/>
-            <a:ext cx="1097280" cy="73152"/>
-          </a:xfrm>
-          <a:prstGeom prst="roundRect">
-            <a:avLst/>
-          </a:prstGeom>
-          <a:solidFill>
-            <a:srgbClr val="06B6D4"/>
-          </a:solidFill>
-          <a:ln>
-            <a:noFill/>
-          </a:ln>
-        </p:spPr>
-        <p:style>
-          <a:lnRef idx="1">
-            <a:schemeClr val="accent1"/>
-          </a:lnRef>
-          <a:fillRef idx="3">
-            <a:schemeClr val="accent1"/>
-          </a:fillRef>
-          <a:effectRef idx="2">
-            <a:schemeClr val="accent1"/>
-          </a:effectRef>
-          <a:fontRef idx="minor">
-            <a:schemeClr val="lt1"/>
-          </a:fontRef>
-        </p:style>
-        <p:txBody>
-          <a:bodyPr rtlCol="0" anchor="ctr"/>
-          <a:lstStyle/>
-          <a:p>
-            <a:pPr algn="ctr"/>
+            <a:endParaRPr/>
           </a:p>
         </p:txBody>
       </p:sp>
@@ -3190,7 +3150,7 @@
         <p:spPr>
           <a:xfrm>
             <a:off x="822960" y="1371600"/>
-            <a:ext cx="10515600" cy="2926080"/>
+            <a:ext cx="10515600" cy="1261884"/>
           </a:xfrm>
           <a:prstGeom prst="rect">
             <a:avLst/>
@@ -3204,42 +3164,22 @@
           <a:lstStyle/>
           <a:p>
             <a:pPr>
-              <a:defRPr sz="1200" b="1">
-                <a:solidFill>
-                  <a:srgbClr val="06B6D4"/>
+              <a:defRPr sz="3800" b="1">
+                <a:solidFill>
+                  <a:srgbClr val="F8FAFC"/>
                 </a:solidFill>
               </a:defRPr>
             </a:pPr>
             <a:r>
-              <a:t>DEFENSIVE CYBERSECURITY &amp; TRAFFIC ANALYSIS</a:t>
-            </a:r>
-          </a:p>
-          <a:p>
-            <a:pPr>
-              <a:defRPr sz="3800" b="1">
-                <a:solidFill>
-                  <a:srgbClr val="F8FAFC"/>
-                </a:solidFill>
-              </a:defRPr>
-            </a:pPr>
-            <a:r>
+              <a:rPr dirty="0"/>
               <a:t>Packet Analysis of</a:t>
             </a:r>
-            <a:br/>
-            <a:r>
+            <a:br>
+              <a:rPr dirty="0"/>
+            </a:br>
+            <a:r>
+              <a:rPr dirty="0"/>
               <a:t>Common Network Protocols</a:t>
-            </a:r>
-          </a:p>
-          <a:p>
-            <a:pPr>
-              <a:defRPr sz="1600">
-                <a:solidFill>
-                  <a:srgbClr val="94A3B8"/>
-                </a:solidFill>
-              </a:defRPr>
-            </a:pPr>
-            <a:r>
-              <a:t>A simple, web-based platform to dissect packets, visualize traffic, and spot anomalies.</a:t>
             </a:r>
           </a:p>
         </p:txBody>
@@ -3282,7 +3222,7 @@
           </a:fontRef>
         </p:style>
         <p:txBody>
-          <a:bodyPr rtlCol="0" anchor="ctr" wrap="square"/>
+          <a:bodyPr wrap="square" rtlCol="0" anchor="ctr"/>
           <a:lstStyle/>
           <a:p>
             <a:pPr algn="ctr">
@@ -3293,11 +3233,12 @@
               </a:defRPr>
             </a:pPr>
             <a:r>
+              <a:rPr dirty="0"/>
               <a:t>COURSE</a:t>
             </a:r>
           </a:p>
           <a:p>
-            <a:pPr>
+            <a:pPr algn="ctr">
               <a:defRPr sz="1300" b="1">
                 <a:solidFill>
                   <a:srgbClr val="F8FAFC"/>
@@ -3305,7 +3246,8 @@
               </a:defRPr>
             </a:pPr>
             <a:r>
-              <a:t>Ethical Hacking / Network Security</a:t>
+              <a:rPr dirty="0"/>
+              <a:t>Ethical Hacking</a:t>
             </a:r>
           </a:p>
         </p:txBody>
@@ -3348,7 +3290,7 @@
           </a:fontRef>
         </p:style>
         <p:txBody>
-          <a:bodyPr rtlCol="0" anchor="ctr" wrap="square"/>
+          <a:bodyPr wrap="square" rtlCol="0" anchor="ctr"/>
           <a:lstStyle/>
           <a:p>
             <a:pPr algn="ctr">
@@ -3359,6 +3301,7 @@
               </a:defRPr>
             </a:pPr>
             <a:r>
+              <a:rPr dirty="0"/>
               <a:t>MODE</a:t>
             </a:r>
           </a:p>
@@ -3371,6 +3314,7 @@
               </a:defRPr>
             </a:pPr>
             <a:r>
+              <a:rPr dirty="0"/>
               <a:t>Strictly Defensive &amp; Passive</a:t>
             </a:r>
           </a:p>
@@ -3414,7 +3358,7 @@
           </a:fontRef>
         </p:style>
         <p:txBody>
-          <a:bodyPr rtlCol="0" anchor="ctr" wrap="square"/>
+          <a:bodyPr wrap="square" rtlCol="0" anchor="ctr"/>
           <a:lstStyle/>
           <a:p>
             <a:pPr algn="ctr">
@@ -3425,11 +3369,13 @@
               </a:defRPr>
             </a:pPr>
             <a:r>
-              <a:t>SETUP</a:t>
-            </a:r>
-          </a:p>
-          <a:p>
-            <a:pPr>
+              <a:rPr lang="en-GB" dirty="0"/>
+              <a:t>TEAM BBC</a:t>
+            </a:r>
+            <a:endParaRPr dirty="0"/>
+          </a:p>
+          <a:p>
+            <a:pPr algn="ctr">
               <a:defRPr sz="1300" b="1">
                 <a:solidFill>
                   <a:srgbClr val="F8FAFC"/>
@@ -3437,8 +3383,22 @@
               </a:defRPr>
             </a:pPr>
             <a:r>
-              <a:t>100% Local (Zero Docker)</a:t>
-            </a:r>
+              <a:rPr lang="en-GB" dirty="0" err="1"/>
+              <a:t>Besita</a:t>
+            </a:r>
+            <a:r>
+              <a:rPr lang="en-GB" dirty="0"/>
+              <a:t>, </a:t>
+            </a:r>
+            <a:r>
+              <a:rPr lang="en-GB" dirty="0" err="1"/>
+              <a:t>Baraneetharan</a:t>
+            </a:r>
+            <a:r>
+              <a:rPr lang="en-GB" dirty="0"/>
+              <a:t> &amp; Chason</a:t>
+            </a:r>
+            <a:endParaRPr dirty="0"/>
           </a:p>
         </p:txBody>
       </p:sp>
@@ -3451,7 +3411,7 @@
 </file>
 
 <file path=ppt/slides/slide2.xml><?xml version="1.0" encoding="utf-8"?>
-<p:sld xmlns:a="http://schemas.openxmlformats.org/drawingml/2006/main" xmlns:p="http://schemas.openxmlformats.org/presentationml/2006/main" xmlns:r="http://schemas.openxmlformats.org/officeDocument/2006/relationships">
+<p:sld xmlns:a="http://schemas.openxmlformats.org/drawingml/2006/main" xmlns:r="http://schemas.openxmlformats.org/officeDocument/2006/relationships" xmlns:p="http://schemas.openxmlformats.org/presentationml/2006/main">
   <p:cSld>
     <p:spTree>
       <p:nvGrpSpPr>
@@ -3459,7 +3419,14 @@
         <p:cNvGrpSpPr/>
         <p:nvPr/>
       </p:nvGrpSpPr>
-      <p:grpSpPr/>
+      <p:grpSpPr>
+        <a:xfrm>
+          <a:off x="0" y="0"/>
+          <a:ext cx="0" cy="0"/>
+          <a:chOff x="0" y="0"/>
+          <a:chExt cx="0" cy="0"/>
+        </a:xfrm>
+      </p:grpSpPr>
       <p:sp>
         <p:nvSpPr>
           <p:cNvPr id="2" name="Rectangle 1"/>
@@ -3500,41 +3467,7 @@
           <a:lstStyle/>
           <a:p>
             <a:pPr algn="ctr"/>
-          </a:p>
-        </p:txBody>
-      </p:sp>
-      <p:sp>
-        <p:nvSpPr>
-          <p:cNvPr id="3" name="TextBox 2"/>
-          <p:cNvSpPr txBox="1"/>
-          <p:nvPr/>
-        </p:nvSpPr>
-        <p:spPr>
-          <a:xfrm>
-            <a:off x="822960" y="502920"/>
-            <a:ext cx="10515600" cy="320040"/>
-          </a:xfrm>
-          <a:prstGeom prst="rect">
-            <a:avLst/>
-          </a:prstGeom>
-          <a:noFill/>
-        </p:spPr>
-        <p:txBody>
-          <a:bodyPr wrap="square">
-            <a:spAutoFit/>
-          </a:bodyPr>
-          <a:lstStyle/>
-          <a:p>
-            <a:pPr>
-              <a:defRPr sz="1000" b="1">
-                <a:solidFill>
-                  <a:srgbClr val="06B6D4"/>
-                </a:solidFill>
-              </a:defRPr>
-            </a:pPr>
-            <a:r>
-              <a:t>NETWORK PROTOCOL INSPECTOR</a:t>
-            </a:r>
+            <a:endParaRPr/>
           </a:p>
         </p:txBody>
       </p:sp>
@@ -3611,7 +3544,7 @@
           </a:fontRef>
         </p:style>
         <p:txBody>
-          <a:bodyPr rtlCol="0" anchor="ctr" wrap="square"/>
+          <a:bodyPr wrap="square" rtlCol="0" anchor="ctr"/>
           <a:lstStyle/>
           <a:p>
             <a:pPr algn="ctr">
@@ -3622,6 +3555,7 @@
               </a:defRPr>
             </a:pPr>
             <a:r>
+              <a:rPr dirty="0"/>
               <a:t>01</a:t>
             </a:r>
           </a:p>
@@ -3634,20 +3568,33 @@
               </a:defRPr>
             </a:pPr>
             <a:r>
+              <a:rPr dirty="0"/>
               <a:t>INGEST</a:t>
             </a:r>
           </a:p>
           <a:p>
-            <a:br/>
-            <a:pPr>
-              <a:defRPr sz="1300">
-                <a:solidFill>
-                  <a:srgbClr val="94A3B8"/>
-                </a:solidFill>
-              </a:defRPr>
-            </a:pPr>
-            <a:r>
-              <a:t>Drop any .pcap or .pcapng file up to 500MB, or load the instant 1-click demo.</a:t>
+            <a:br>
+              <a:rPr dirty="0"/>
+            </a:br>
+            <a:r>
+              <a:rPr dirty="0"/>
+              <a:t>Drop any .</a:t>
+            </a:r>
+            <a:r>
+              <a:rPr dirty="0" err="1"/>
+              <a:t>pcap</a:t>
+            </a:r>
+            <a:r>
+              <a:rPr dirty="0"/>
+              <a:t> or .</a:t>
+            </a:r>
+            <a:r>
+              <a:rPr dirty="0" err="1"/>
+              <a:t>pcapng</a:t>
+            </a:r>
+            <a:r>
+              <a:rPr dirty="0"/>
+              <a:t> file up to 500MB, or load the demo.</a:t>
             </a:r>
           </a:p>
         </p:txBody>
@@ -3690,7 +3637,7 @@
           </a:fontRef>
         </p:style>
         <p:txBody>
-          <a:bodyPr rtlCol="0" anchor="ctr" wrap="square"/>
+          <a:bodyPr wrap="square" rtlCol="0" anchor="ctr"/>
           <a:lstStyle/>
           <a:p>
             <a:pPr algn="ctr">
@@ -3718,13 +3665,6 @@
           </a:p>
           <a:p>
             <a:br/>
-            <a:pPr>
-              <a:defRPr sz="1300">
-                <a:solidFill>
-                  <a:srgbClr val="94A3B8"/>
-                </a:solidFill>
-              </a:defRPr>
-            </a:pPr>
             <a:r>
               <a:t>Automatically unpack every layer from Ethernet to IP, TCP, DNS, and TLS.</a:t>
             </a:r>
@@ -3769,7 +3709,7 @@
           </a:fontRef>
         </p:style>
         <p:txBody>
-          <a:bodyPr rtlCol="0" anchor="ctr" wrap="square"/>
+          <a:bodyPr wrap="square" rtlCol="0" anchor="ctr"/>
           <a:lstStyle/>
           <a:p>
             <a:pPr algn="ctr">
@@ -3797,13 +3737,6 @@
           </a:p>
           <a:p>
             <a:br/>
-            <a:pPr>
-              <a:defRPr sz="1300">
-                <a:solidFill>
-                  <a:srgbClr val="94A3B8"/>
-                </a:solidFill>
-              </a:defRPr>
-            </a:pPr>
             <a:r>
               <a:t>Spot port scans, SYN floods, cleartext passwords, and DNS anomalies in seconds.</a:t>
             </a:r>
@@ -3819,7 +3752,7 @@
 </file>
 
 <file path=ppt/slides/slide3.xml><?xml version="1.0" encoding="utf-8"?>
-<p:sld xmlns:a="http://schemas.openxmlformats.org/drawingml/2006/main" xmlns:p="http://schemas.openxmlformats.org/presentationml/2006/main" xmlns:r="http://schemas.openxmlformats.org/officeDocument/2006/relationships">
+<p:sld xmlns:a="http://schemas.openxmlformats.org/drawingml/2006/main" xmlns:r="http://schemas.openxmlformats.org/officeDocument/2006/relationships" xmlns:p="http://schemas.openxmlformats.org/presentationml/2006/main">
   <p:cSld>
     <p:spTree>
       <p:nvGrpSpPr>
@@ -3827,7 +3760,14 @@
         <p:cNvGrpSpPr/>
         <p:nvPr/>
       </p:nvGrpSpPr>
-      <p:grpSpPr/>
+      <p:grpSpPr>
+        <a:xfrm>
+          <a:off x="0" y="0"/>
+          <a:ext cx="0" cy="0"/>
+          <a:chOff x="0" y="0"/>
+          <a:chExt cx="0" cy="0"/>
+        </a:xfrm>
+      </p:grpSpPr>
       <p:sp>
         <p:nvSpPr>
           <p:cNvPr id="2" name="Rectangle 1"/>
@@ -3868,6 +3808,7 @@
           <a:lstStyle/>
           <a:p>
             <a:pPr algn="ctr"/>
+            <a:endParaRPr/>
           </a:p>
         </p:txBody>
       </p:sp>
@@ -3979,7 +3920,7 @@
           </a:fontRef>
         </p:style>
         <p:txBody>
-          <a:bodyPr rtlCol="0" anchor="ctr" wrap="square"/>
+          <a:bodyPr wrap="square" rtlCol="0" anchor="ctr"/>
           <a:lstStyle/>
           <a:p>
             <a:pPr algn="ctr">
@@ -4007,13 +3948,6 @@
           </a:p>
           <a:p>
             <a:br/>
-            <a:pPr>
-              <a:defRPr sz="1200">
-                <a:solidFill>
-                  <a:srgbClr val="94A3B8"/>
-                </a:solidFill>
-              </a:defRPr>
-            </a:pPr>
             <a:r>
               <a:t>Accepts standard .pcap / .pcapng files up to 500MB.</a:t>
             </a:r>
@@ -4058,7 +3992,7 @@
           </a:fontRef>
         </p:style>
         <p:txBody>
-          <a:bodyPr rtlCol="0" anchor="ctr" wrap="square"/>
+          <a:bodyPr wrap="square" rtlCol="0" anchor="ctr"/>
           <a:lstStyle/>
           <a:p>
             <a:pPr algn="ctr">
@@ -4086,13 +4020,6 @@
           </a:p>
           <a:p>
             <a:br/>
-            <a:pPr>
-              <a:defRPr sz="1200">
-                <a:solidFill>
-                  <a:srgbClr val="94A3B8"/>
-                </a:solidFill>
-              </a:defRPr>
-            </a:pPr>
             <a:r>
               <a:t>Dissects Ethernet, IP, TCP, UDP, ICMP, DNS &amp; TLS.</a:t>
             </a:r>
@@ -4137,7 +4064,7 @@
           </a:fontRef>
         </p:style>
         <p:txBody>
-          <a:bodyPr rtlCol="0" anchor="ctr" wrap="square"/>
+          <a:bodyPr wrap="square" rtlCol="0" anchor="ctr"/>
           <a:lstStyle/>
           <a:p>
             <a:pPr algn="ctr">
@@ -4165,13 +4092,6 @@
           </a:p>
           <a:p>
             <a:br/>
-            <a:pPr>
-              <a:defRPr sz="1200">
-                <a:solidFill>
-                  <a:srgbClr val="94A3B8"/>
-                </a:solidFill>
-              </a:defRPr>
-            </a:pPr>
             <a:r>
               <a:t>Evaluates 8 heuristic checks for scans and leaks.</a:t>
             </a:r>
@@ -4216,7 +4136,7 @@
           </a:fontRef>
         </p:style>
         <p:txBody>
-          <a:bodyPr rtlCol="0" anchor="ctr" wrap="square"/>
+          <a:bodyPr wrap="square" rtlCol="0" anchor="ctr"/>
           <a:lstStyle/>
           <a:p>
             <a:pPr algn="ctr">
@@ -4227,6 +4147,7 @@
               </a:defRPr>
             </a:pPr>
             <a:r>
+              <a:rPr dirty="0"/>
               <a:t>STEP 4</a:t>
             </a:r>
           </a:p>
@@ -4239,20 +4160,17 @@
               </a:defRPr>
             </a:pPr>
             <a:r>
+              <a:rPr dirty="0"/>
               <a:t>Interactive UI</a:t>
             </a:r>
           </a:p>
           <a:p>
-            <a:br/>
-            <a:pPr>
-              <a:defRPr sz="1200">
-                <a:solidFill>
-                  <a:srgbClr val="94A3B8"/>
-                </a:solidFill>
-              </a:defRPr>
-            </a:pPr>
-            <a:r>
-              <a:t>Live charts, Wireshark grid, and 1-click PDF reports.</a:t>
+            <a:br>
+              <a:rPr dirty="0"/>
+            </a:br>
+            <a:r>
+              <a:rPr dirty="0"/>
+              <a:t>Live charts, Wireshark grid, and PDF reports.</a:t>
             </a:r>
           </a:p>
         </p:txBody>
@@ -4266,7 +4184,7 @@
 </file>
 
 <file path=ppt/slides/slide4.xml><?xml version="1.0" encoding="utf-8"?>
-<p:sld xmlns:a="http://schemas.openxmlformats.org/drawingml/2006/main" xmlns:p="http://schemas.openxmlformats.org/presentationml/2006/main" xmlns:r="http://schemas.openxmlformats.org/officeDocument/2006/relationships">
+<p:sld xmlns:a="http://schemas.openxmlformats.org/drawingml/2006/main" xmlns:r="http://schemas.openxmlformats.org/officeDocument/2006/relationships" xmlns:p="http://schemas.openxmlformats.org/presentationml/2006/main">
   <p:cSld>
     <p:spTree>
       <p:nvGrpSpPr>
@@ -4274,7 +4192,14 @@
         <p:cNvGrpSpPr/>
         <p:nvPr/>
       </p:nvGrpSpPr>
-      <p:grpSpPr/>
+      <p:grpSpPr>
+        <a:xfrm>
+          <a:off x="0" y="0"/>
+          <a:ext cx="0" cy="0"/>
+          <a:chOff x="0" y="0"/>
+          <a:chExt cx="0" cy="0"/>
+        </a:xfrm>
+      </p:grpSpPr>
       <p:sp>
         <p:nvSpPr>
           <p:cNvPr id="2" name="Rectangle 1"/>
@@ -4315,6 +4240,7 @@
           <a:lstStyle/>
           <a:p>
             <a:pPr algn="ctr"/>
+            <a:endParaRPr/>
           </a:p>
         </p:txBody>
       </p:sp>
@@ -4362,7 +4288,7 @@
         <p:spPr>
           <a:xfrm>
             <a:off x="822960" y="777240"/>
-            <a:ext cx="10515600" cy="685800"/>
+            <a:ext cx="10515600" cy="461665"/>
           </a:xfrm>
           <a:prstGeom prst="rect">
             <a:avLst/>
@@ -4383,7 +4309,8 @@
               </a:defRPr>
             </a:pPr>
             <a:r>
-              <a:t>Full-Stack Protocol Coverage (L2 to L7)</a:t>
+              <a:rPr dirty="0"/>
+              <a:t>Protocol Coverage (L2 to L7)</a:t>
             </a:r>
           </a:p>
         </p:txBody>
@@ -4426,7 +4353,7 @@
           </a:fontRef>
         </p:style>
         <p:txBody>
-          <a:bodyPr rtlCol="0" anchor="ctr" wrap="square"/>
+          <a:bodyPr wrap="square" rtlCol="0" anchor="ctr"/>
           <a:lstStyle/>
           <a:p>
             <a:pPr algn="ctr">
@@ -4492,7 +4419,7 @@
           </a:fontRef>
         </p:style>
         <p:txBody>
-          <a:bodyPr rtlCol="0" anchor="ctr" wrap="square"/>
+          <a:bodyPr wrap="square" rtlCol="0" anchor="ctr"/>
           <a:lstStyle/>
           <a:p>
             <a:pPr algn="ctr">
@@ -4558,7 +4485,7 @@
           </a:fontRef>
         </p:style>
         <p:txBody>
-          <a:bodyPr rtlCol="0" anchor="ctr" wrap="square"/>
+          <a:bodyPr wrap="square" rtlCol="0" anchor="ctr"/>
           <a:lstStyle/>
           <a:p>
             <a:pPr algn="ctr">
@@ -4624,7 +4551,7 @@
           </a:fontRef>
         </p:style>
         <p:txBody>
-          <a:bodyPr rtlCol="0" anchor="ctr" wrap="square"/>
+          <a:bodyPr wrap="square" rtlCol="0" anchor="ctr"/>
           <a:lstStyle/>
           <a:p>
             <a:pPr algn="ctr">
@@ -4661,7 +4588,7 @@
 </file>
 
 <file path=ppt/slides/slide5.xml><?xml version="1.0" encoding="utf-8"?>
-<p:sld xmlns:a="http://schemas.openxmlformats.org/drawingml/2006/main" xmlns:p="http://schemas.openxmlformats.org/presentationml/2006/main" xmlns:r="http://schemas.openxmlformats.org/officeDocument/2006/relationships">
+<p:sld xmlns:a="http://schemas.openxmlformats.org/drawingml/2006/main" xmlns:r="http://schemas.openxmlformats.org/officeDocument/2006/relationships" xmlns:p="http://schemas.openxmlformats.org/presentationml/2006/main">
   <p:cSld>
     <p:spTree>
       <p:nvGrpSpPr>
@@ -4669,7 +4596,14 @@
         <p:cNvGrpSpPr/>
         <p:nvPr/>
       </p:nvGrpSpPr>
-      <p:grpSpPr/>
+      <p:grpSpPr>
+        <a:xfrm>
+          <a:off x="0" y="0"/>
+          <a:ext cx="0" cy="0"/>
+          <a:chOff x="0" y="0"/>
+          <a:chExt cx="0" cy="0"/>
+        </a:xfrm>
+      </p:grpSpPr>
       <p:sp>
         <p:nvSpPr>
           <p:cNvPr id="2" name="Rectangle 1"/>
@@ -4710,6 +4644,7 @@
           <a:lstStyle/>
           <a:p>
             <a:pPr algn="ctr"/>
+            <a:endParaRPr/>
           </a:p>
         </p:txBody>
       </p:sp>
@@ -4821,7 +4756,7 @@
           </a:fontRef>
         </p:style>
         <p:txBody>
-          <a:bodyPr rtlCol="0" anchor="ctr" wrap="square"/>
+          <a:bodyPr wrap="square" rtlCol="0" anchor="ctr"/>
           <a:lstStyle/>
           <a:p>
             <a:pPr algn="ctr">
@@ -4837,13 +4772,6 @@
           </a:p>
           <a:p>
             <a:br/>
-            <a:pPr>
-              <a:defRPr sz="1200">
-                <a:solidFill>
-                  <a:srgbClr val="F8FAFC"/>
-                </a:solidFill>
-              </a:defRPr>
-            </a:pPr>
             <a:r>
               <a:t>High-level overview: total packets, bytes, unique IPs, protocol doughnut chart, and MTU packet size histogram.</a:t>
             </a:r>
@@ -4888,7 +4816,7 @@
           </a:fontRef>
         </p:style>
         <p:txBody>
-          <a:bodyPr rtlCol="0" anchor="ctr" wrap="square"/>
+          <a:bodyPr wrap="square" rtlCol="0" anchor="ctr"/>
           <a:lstStyle/>
           <a:p>
             <a:pPr algn="ctr">
@@ -4904,13 +4832,6 @@
           </a:p>
           <a:p>
             <a:br/>
-            <a:pPr>
-              <a:defRPr sz="1200">
-                <a:solidFill>
-                  <a:srgbClr val="F8FAFC"/>
-                </a:solidFill>
-              </a:defRPr>
-            </a:pPr>
             <a:r>
               <a:t>Wireshark-style sortable table with instant search, protocol filters, collapsible layer tree, and hex dump.</a:t>
             </a:r>
@@ -4955,7 +4876,7 @@
           </a:fontRef>
         </p:style>
         <p:txBody>
-          <a:bodyPr rtlCol="0" anchor="ctr" wrap="square"/>
+          <a:bodyPr wrap="square" rtlCol="0" anchor="ctr"/>
           <a:lstStyle/>
           <a:p>
             <a:pPr algn="ctr">
@@ -4971,13 +4892,6 @@
           </a:p>
           <a:p>
             <a:br/>
-            <a:pPr>
-              <a:defRPr sz="1200">
-                <a:solidFill>
-                  <a:srgbClr val="F8FAFC"/>
-                </a:solidFill>
-              </a:defRPr>
-            </a:pPr>
             <a:r>
               <a:t>Tracks bidirectional communication pairs (Host A &lt;-&gt; Host B), bytes transferred, and session durations.</a:t>
             </a:r>
@@ -5022,7 +4936,7 @@
           </a:fontRef>
         </p:style>
         <p:txBody>
-          <a:bodyPr rtlCol="0" anchor="ctr" wrap="square"/>
+          <a:bodyPr wrap="square" rtlCol="0" anchor="ctr"/>
           <a:lstStyle/>
           <a:p>
             <a:pPr algn="ctr">
@@ -5038,13 +4952,6 @@
           </a:p>
           <a:p>
             <a:br/>
-            <a:pPr>
-              <a:defRPr sz="1200">
-                <a:solidFill>
-                  <a:srgbClr val="F8FAFC"/>
-                </a:solidFill>
-              </a:defRPr>
-            </a:pPr>
             <a:r>
               <a:t>Host directory showing top talkers, plus destination ports mapped to recognized services (443-&gt;HTTPS, 53-&gt;DNS).</a:t>
             </a:r>
@@ -5060,7 +4967,7 @@
 </file>
 
 <file path=ppt/slides/slide6.xml><?xml version="1.0" encoding="utf-8"?>
-<p:sld xmlns:a="http://schemas.openxmlformats.org/drawingml/2006/main" xmlns:p="http://schemas.openxmlformats.org/presentationml/2006/main" xmlns:r="http://schemas.openxmlformats.org/officeDocument/2006/relationships">
+<p:sld xmlns:a="http://schemas.openxmlformats.org/drawingml/2006/main" xmlns:r="http://schemas.openxmlformats.org/officeDocument/2006/relationships" xmlns:p="http://schemas.openxmlformats.org/presentationml/2006/main">
   <p:cSld>
     <p:spTree>
       <p:nvGrpSpPr>
@@ -5068,7 +4975,14 @@
         <p:cNvGrpSpPr/>
         <p:nvPr/>
       </p:nvGrpSpPr>
-      <p:grpSpPr/>
+      <p:grpSpPr>
+        <a:xfrm>
+          <a:off x="0" y="0"/>
+          <a:ext cx="0" cy="0"/>
+          <a:chOff x="0" y="0"/>
+          <a:chExt cx="0" cy="0"/>
+        </a:xfrm>
+      </p:grpSpPr>
       <p:sp>
         <p:nvSpPr>
           <p:cNvPr id="2" name="Rectangle 1"/>
@@ -5109,6 +5023,7 @@
           <a:lstStyle/>
           <a:p>
             <a:pPr algn="ctr"/>
+            <a:endParaRPr/>
           </a:p>
         </p:txBody>
       </p:sp>
@@ -5220,7 +5135,7 @@
           </a:fontRef>
         </p:style>
         <p:txBody>
-          <a:bodyPr rtlCol="0" anchor="ctr" wrap="square"/>
+          <a:bodyPr wrap="square" rtlCol="0" anchor="ctr"/>
           <a:lstStyle/>
           <a:p>
             <a:pPr algn="ctr">
@@ -5248,13 +5163,6 @@
           </a:p>
           <a:p>
             <a:br/>
-            <a:pPr>
-              <a:defRPr sz="1200">
-                <a:solidFill>
-                  <a:srgbClr val="94A3B8"/>
-                </a:solidFill>
-              </a:defRPr>
-            </a:pPr>
             <a:r>
               <a:t>Flags single hosts probing multiple ports within short time windows.</a:t>
             </a:r>
@@ -5299,7 +5207,7 @@
           </a:fontRef>
         </p:style>
         <p:txBody>
-          <a:bodyPr rtlCol="0" anchor="ctr" wrap="square"/>
+          <a:bodyPr wrap="square" rtlCol="0" anchor="ctr"/>
           <a:lstStyle/>
           <a:p>
             <a:pPr algn="ctr">
@@ -5327,13 +5235,6 @@
           </a:p>
           <a:p>
             <a:br/>
-            <a:pPr>
-              <a:defRPr sz="1200">
-                <a:solidFill>
-                  <a:srgbClr val="94A3B8"/>
-                </a:solidFill>
-              </a:defRPr>
-            </a:pPr>
             <a:r>
               <a:t>Identifies abnormal bursts of SYN packets with no completed handshakes.</a:t>
             </a:r>
@@ -5378,7 +5279,7 @@
           </a:fontRef>
         </p:style>
         <p:txBody>
-          <a:bodyPr rtlCol="0" anchor="ctr" wrap="square"/>
+          <a:bodyPr wrap="square" rtlCol="0" anchor="ctr"/>
           <a:lstStyle/>
           <a:p>
             <a:pPr algn="ctr">
@@ -5406,13 +5307,6 @@
           </a:p>
           <a:p>
             <a:br/>
-            <a:pPr>
-              <a:defRPr sz="1200">
-                <a:solidFill>
-                  <a:srgbClr val="94A3B8"/>
-                </a:solidFill>
-              </a:defRPr>
-            </a:pPr>
             <a:r>
               <a:t>Catches unusually long domain queries (&gt;45 chars) or high entropy names.</a:t>
             </a:r>
@@ -5457,7 +5351,7 @@
           </a:fontRef>
         </p:style>
         <p:txBody>
-          <a:bodyPr rtlCol="0" anchor="ctr" wrap="square"/>
+          <a:bodyPr wrap="square" rtlCol="0" anchor="ctr"/>
           <a:lstStyle/>
           <a:p>
             <a:pPr algn="ctr">
@@ -5485,13 +5379,6 @@
           </a:p>
           <a:p>
             <a:br/>
-            <a:pPr>
-              <a:defRPr sz="1200">
-                <a:solidFill>
-                  <a:srgbClr val="94A3B8"/>
-                </a:solidFill>
-              </a:defRPr>
-            </a:pPr>
             <a:r>
               <a:t>Flags unencrypted HTTP forms sending authentication credentials in the clear.</a:t>
             </a:r>
@@ -5507,7 +5394,7 @@
 </file>
 
 <file path=ppt/slides/slide7.xml><?xml version="1.0" encoding="utf-8"?>
-<p:sld xmlns:a="http://schemas.openxmlformats.org/drawingml/2006/main" xmlns:p="http://schemas.openxmlformats.org/presentationml/2006/main" xmlns:r="http://schemas.openxmlformats.org/officeDocument/2006/relationships">
+<p:sld xmlns:a="http://schemas.openxmlformats.org/drawingml/2006/main" xmlns:r="http://schemas.openxmlformats.org/officeDocument/2006/relationships" xmlns:p="http://schemas.openxmlformats.org/presentationml/2006/main">
   <p:cSld>
     <p:spTree>
       <p:nvGrpSpPr>
@@ -5515,7 +5402,14 @@
         <p:cNvGrpSpPr/>
         <p:nvPr/>
       </p:nvGrpSpPr>
-      <p:grpSpPr/>
+      <p:grpSpPr>
+        <a:xfrm>
+          <a:off x="0" y="0"/>
+          <a:ext cx="0" cy="0"/>
+          <a:chOff x="0" y="0"/>
+          <a:chExt cx="0" cy="0"/>
+        </a:xfrm>
+      </p:grpSpPr>
       <p:sp>
         <p:nvSpPr>
           <p:cNvPr id="2" name="Rectangle 1"/>
@@ -5556,6 +5450,7 @@
           <a:lstStyle/>
           <a:p>
             <a:pPr algn="ctr"/>
+            <a:endParaRPr/>
           </a:p>
         </p:txBody>
       </p:sp>
@@ -5667,7 +5562,7 @@
           </a:fontRef>
         </p:style>
         <p:txBody>
-          <a:bodyPr rtlCol="0" anchor="ctr" wrap="square"/>
+          <a:bodyPr wrap="square" rtlCol="0" anchor="ctr"/>
           <a:lstStyle/>
           <a:p>
             <a:pPr algn="ctr">
@@ -5695,13 +5590,6 @@
           </a:p>
           <a:p>
             <a:br/>
-            <a:pPr>
-              <a:defRPr sz="1200">
-                <a:solidFill>
-                  <a:srgbClr val="94A3B8"/>
-                </a:solidFill>
-              </a:defRPr>
-            </a:pPr>
             <a:r>
               <a:t>Modern cybersecurity dark theme using Tailwind CSS and Lucide icons.</a:t>
             </a:r>
@@ -5759,7 +5647,7 @@
           </a:fontRef>
         </p:style>
         <p:txBody>
-          <a:bodyPr rtlCol="0" anchor="ctr" wrap="square"/>
+          <a:bodyPr wrap="square" rtlCol="0" anchor="ctr"/>
           <a:lstStyle/>
           <a:p>
             <a:pPr algn="ctr">
@@ -5787,13 +5675,6 @@
           </a:p>
           <a:p>
             <a:br/>
-            <a:pPr>
-              <a:defRPr sz="1200">
-                <a:solidFill>
-                  <a:srgbClr val="94A3B8"/>
-                </a:solidFill>
-              </a:defRPr>
-            </a:pPr>
             <a:r>
               <a:t>Streaming packet parser using Scapy with asynchronous REST APIs.</a:t>
             </a:r>
@@ -5851,7 +5732,7 @@
           </a:fontRef>
         </p:style>
         <p:txBody>
-          <a:bodyPr rtlCol="0" anchor="ctr" wrap="square"/>
+          <a:bodyPr wrap="square" rtlCol="0" anchor="ctr"/>
           <a:lstStyle/>
           <a:p>
             <a:pPr algn="ctr">
@@ -5879,13 +5760,6 @@
           </a:p>
           <a:p>
             <a:br/>
-            <a:pPr>
-              <a:defRPr sz="1200">
-                <a:solidFill>
-                  <a:srgbClr val="94A3B8"/>
-                </a:solidFill>
-              </a:defRPr>
-            </a:pPr>
             <a:r>
               <a:t>Zero Docker needed. All capture data stored locally in network_analysis.db.</a:t>
             </a:r>
@@ -5914,7 +5788,7 @@
 </file>
 
 <file path=ppt/slides/slide8.xml><?xml version="1.0" encoding="utf-8"?>
-<p:sld xmlns:a="http://schemas.openxmlformats.org/drawingml/2006/main" xmlns:p="http://schemas.openxmlformats.org/presentationml/2006/main" xmlns:r="http://schemas.openxmlformats.org/officeDocument/2006/relationships">
+<p:sld xmlns:a="http://schemas.openxmlformats.org/drawingml/2006/main" xmlns:r="http://schemas.openxmlformats.org/officeDocument/2006/relationships" xmlns:p="http://schemas.openxmlformats.org/presentationml/2006/main">
   <p:cSld>
     <p:spTree>
       <p:nvGrpSpPr>
@@ -5922,7 +5796,14 @@
         <p:cNvGrpSpPr/>
         <p:nvPr/>
       </p:nvGrpSpPr>
-      <p:grpSpPr/>
+      <p:grpSpPr>
+        <a:xfrm>
+          <a:off x="0" y="0"/>
+          <a:ext cx="0" cy="0"/>
+          <a:chOff x="0" y="0"/>
+          <a:chExt cx="0" cy="0"/>
+        </a:xfrm>
+      </p:grpSpPr>
       <p:sp>
         <p:nvSpPr>
           <p:cNvPr id="2" name="Rectangle 1"/>
@@ -5963,6 +5844,7 @@
           <a:lstStyle/>
           <a:p>
             <a:pPr algn="ctr"/>
+            <a:endParaRPr/>
           </a:p>
         </p:txBody>
       </p:sp>
@@ -6074,7 +5956,7 @@
           </a:fontRef>
         </p:style>
         <p:txBody>
-          <a:bodyPr rtlCol="0" anchor="ctr" wrap="square"/>
+          <a:bodyPr wrap="square" rtlCol="0" anchor="ctr"/>
           <a:lstStyle/>
           <a:p>
             <a:pPr algn="ctr">
@@ -6090,13 +5972,6 @@
           </a:p>
           <a:p>
             <a:br/>
-            <a:pPr>
-              <a:defRPr sz="1200">
-                <a:solidFill>
-                  <a:srgbClr val="F8FAFC"/>
-                </a:solidFill>
-              </a:defRPr>
-            </a:pPr>
             <a:r>
               <a:t>Exports an executive audit report with capture stats and security findings ready for submission.</a:t>
             </a:r>
@@ -6141,7 +6016,7 @@
           </a:fontRef>
         </p:style>
         <p:txBody>
-          <a:bodyPr rtlCol="0" anchor="ctr" wrap="square"/>
+          <a:bodyPr wrap="square" rtlCol="0" anchor="ctr"/>
           <a:lstStyle/>
           <a:p>
             <a:pPr algn="ctr">
@@ -6157,13 +6032,6 @@
           </a:p>
           <a:p>
             <a:br/>
-            <a:pPr>
-              <a:defRPr sz="1200">
-                <a:solidFill>
-                  <a:srgbClr val="F8FAFC"/>
-                </a:solidFill>
-              </a:defRPr>
-            </a:pPr>
             <a:r>
               <a:t>Interactive TCP 3-way handshake diagram and 15+ curated viva exam questions with answers.</a:t>
             </a:r>
@@ -6208,7 +6076,7 @@
           </a:fontRef>
         </p:style>
         <p:txBody>
-          <a:bodyPr rtlCol="0" anchor="ctr" wrap="square"/>
+          <a:bodyPr wrap="square" rtlCol="0" anchor="ctr"/>
           <a:lstStyle/>
           <a:p>
             <a:pPr algn="ctr">
@@ -6224,13 +6092,6 @@
           </a:p>
           <a:p>
             <a:br/>
-            <a:pPr>
-              <a:defRPr sz="1200">
-                <a:solidFill>
-                  <a:srgbClr val="F8FAFC"/>
-                </a:solidFill>
-              </a:defRPr>
-            </a:pPr>
             <a:r>
               <a:t>Comprehensive test suite covering endpoints, Scapy parsing, and security rules.</a:t>
             </a:r>
@@ -6275,7 +6136,7 @@
           </a:fontRef>
         </p:style>
         <p:txBody>
-          <a:bodyPr rtlCol="0" anchor="ctr" wrap="square"/>
+          <a:bodyPr wrap="square" rtlCol="0" anchor="ctr"/>
           <a:lstStyle/>
           <a:p>
             <a:pPr algn="ctr">
@@ -6291,13 +6152,6 @@
           </a:p>
           <a:p>
             <a:br/>
-            <a:pPr>
-              <a:defRPr sz="1200">
-                <a:solidFill>
-                  <a:srgbClr val="F8FAFC"/>
-                </a:solidFill>
-              </a:defRPr>
-            </a:pPr>
             <a:r>
               <a:t>Pre-packaged multi-protocol capture with realistic scan patterns to test instantly.</a:t>
             </a:r>

</xml_diff>